<commit_message>
Update presentation PPTX with Python SDK details and 50/50 test counts
</commit_message>
<xml_diff>
--- a/Samsung_PRISM_Generative_AI_Hackathon_Presentation_Updated.pptx
+++ b/Samsung_PRISM_Generative_AI_Hackathon_Presentation_Updated.pptx
@@ -4133,76 +4133,7 @@
               </a:spcAft>
             </a:pPr>
             <a:r>
-              <a:rPr sz="2200" b="1" dirty="0">
-                <a:solidFill>
-                  <a:srgbClr val="1E1E2D"/>
-                </a:solidFill>
-              </a:rPr>
-              <a:t>• Official Evaluation &amp; Indexing: MTEB v2.21.8 (</a:t>
-            </a:r>
-            <a:r>
-              <a:rPr sz="2200" b="1" dirty="0" err="1">
-                <a:solidFill>
-                  <a:srgbClr val="1E1E2D"/>
-                </a:solidFill>
-              </a:rPr>
-              <a:t>EncoderProtocol</a:t>
-            </a:r>
-            <a:r>
-              <a:rPr sz="2200" b="1" dirty="0">
-                <a:solidFill>
-                  <a:srgbClr val="1E1E2D"/>
-                </a:solidFill>
-              </a:rPr>
-              <a:t> + </a:t>
-            </a:r>
-            <a:r>
-              <a:rPr sz="2200" b="1" dirty="0" err="1">
-                <a:solidFill>
-                  <a:srgbClr val="1E1E2D"/>
-                </a:solidFill>
-              </a:rPr>
-              <a:t>SearchProtocol</a:t>
-            </a:r>
-            <a:r>
-              <a:rPr sz="2200" b="1" dirty="0">
-                <a:solidFill>
-                  <a:srgbClr val="1E1E2D"/>
-                </a:solidFill>
-              </a:rPr>
-              <a:t> compliance), FAISS </a:t>
-            </a:r>
-            <a:r>
-              <a:rPr sz="2200" b="1" dirty="0" err="1">
-                <a:solidFill>
-                  <a:srgbClr val="1E1E2D"/>
-                </a:solidFill>
-              </a:rPr>
-              <a:t>IndexFlatIP</a:t>
-            </a:r>
-            <a:r>
-              <a:rPr sz="2200" b="1" dirty="0">
-                <a:solidFill>
-                  <a:srgbClr val="1E1E2D"/>
-                </a:solidFill>
-              </a:rPr>
-              <a:t>, and 42 </a:t>
-            </a:r>
-            <a:r>
-              <a:rPr sz="2200" b="1" dirty="0" err="1">
-                <a:solidFill>
-                  <a:srgbClr val="1E1E2D"/>
-                </a:solidFill>
-              </a:rPr>
-              <a:t>pytest</a:t>
-            </a:r>
-            <a:r>
-              <a:rPr sz="2200" b="1" dirty="0">
-                <a:solidFill>
-                  <a:srgbClr val="1E1E2D"/>
-                </a:solidFill>
-              </a:rPr>
-              <a:t> unit tests</a:t>
+              <a:t>• Official Evaluation, Indexing &amp; SDK: MTEB v2.21.8 compliance, FAISS IndexFlatIP, 50 automated pytest unit tests (100%), and Developer Python SDK (agentic_code_intelligence v1.0.0 wheel in dist/)</a:t>
             </a:r>
           </a:p>
         </p:txBody>
@@ -5502,28 +5433,7 @@
               </a:spcAft>
             </a:pPr>
             <a:r>
-              <a:rPr sz="2400" b="1" dirty="0">
-                <a:solidFill>
-                  <a:srgbClr val="6A0DAD"/>
-                </a:solidFill>
-              </a:rPr>
-              <a:t>4. Native MTEB 2.x </a:t>
-            </a:r>
-            <a:r>
-              <a:rPr sz="2400" b="1" dirty="0" err="1">
-                <a:solidFill>
-                  <a:srgbClr val="6A0DAD"/>
-                </a:solidFill>
-              </a:rPr>
-              <a:t>SearchProtocol</a:t>
-            </a:r>
-            <a:r>
-              <a:rPr sz="2400" b="1" dirty="0">
-                <a:solidFill>
-                  <a:srgbClr val="6A0DAD"/>
-                </a:solidFill>
-              </a:rPr>
-              <a:t> + Version-Aware Indexing + 42/42 Unit Tests</a:t>
+              <a:t>4. Native MTEB 2.x Protocol + Python SDK + 50/50 Unit Tests</a:t>
             </a:r>
           </a:p>
           <a:p>
@@ -5533,60 +5443,7 @@
               </a:spcAft>
             </a:pPr>
             <a:r>
-              <a:rPr b="0" dirty="0">
-                <a:solidFill>
-                  <a:srgbClr val="505060"/>
-                </a:solidFill>
-              </a:rPr>
-              <a:t>Implements both MTEB 2.x </a:t>
-            </a:r>
-            <a:r>
-              <a:rPr b="0" dirty="0" err="1">
-                <a:solidFill>
-                  <a:srgbClr val="505060"/>
-                </a:solidFill>
-              </a:rPr>
-              <a:t>EncoderProtocol</a:t>
-            </a:r>
-            <a:r>
-              <a:rPr b="0" dirty="0">
-                <a:solidFill>
-                  <a:srgbClr val="505060"/>
-                </a:solidFill>
-              </a:rPr>
-              <a:t> and </a:t>
-            </a:r>
-            <a:r>
-              <a:rPr b="0" dirty="0" err="1">
-                <a:solidFill>
-                  <a:srgbClr val="505060"/>
-                </a:solidFill>
-              </a:rPr>
-              <a:t>SearchProtocol</a:t>
-            </a:r>
-            <a:r>
-              <a:rPr b="0" dirty="0">
-                <a:solidFill>
-                  <a:srgbClr val="505060"/>
-                </a:solidFill>
-              </a:rPr>
-              <a:t>, supports multi-version index isolation, and passes 42/42 automated </a:t>
-            </a:r>
-            <a:r>
-              <a:rPr b="0" dirty="0" err="1">
-                <a:solidFill>
-                  <a:srgbClr val="505060"/>
-                </a:solidFill>
-              </a:rPr>
-              <a:t>pytest</a:t>
-            </a:r>
-            <a:r>
-              <a:rPr b="0" dirty="0">
-                <a:solidFill>
-                  <a:srgbClr val="505060"/>
-                </a:solidFill>
-              </a:rPr>
-              <a:t> unit tests (100%).</a:t>
+              <a:t>Implements MTEB 2.x SearchProtocol, ships prebuilt Python SDK wheel (agentic_code_intelligence v1.0.0), supports multi-version index isolation, and passes 50/50 automated pytest unit tests (100%).</a:t>
             </a:r>
           </a:p>
         </p:txBody>
@@ -5827,29 +5684,7 @@
               </a:spcAft>
             </a:pPr>
             <a:r>
-              <a:rPr sz="2800" b="1" dirty="0">
-                <a:solidFill>
-                  <a:srgbClr val="6A0DAD"/>
-                </a:solidFill>
-              </a:rPr>
-              <a:t>• Demo video</a:t>
-            </a:r>
-            <a:r>
-              <a:rPr lang="en-US" sz="2800" b="1" dirty="0">
-                <a:solidFill>
-                  <a:srgbClr val="6A0DAD"/>
-                </a:solidFill>
-              </a:rPr>
-              <a:t>: </a:t>
-            </a:r>
-            <a:r>
-              <a:rPr lang="en-US" sz="2800" b="1" dirty="0">
-                <a:solidFill>
-                  <a:srgbClr val="6A0DAD"/>
-                </a:solidFill>
-                <a:hlinkClick r:id="rId3"/>
-              </a:rPr>
-              <a:t>https://drive.google.com/file/d/1JQQXUEOY81HSYag60_mDM9-FCE1qdSzh/view?usp=sharing</a:t>
+              <a:t>• Demo video: Demo.mp4 (in repository, 20MB) &amp; Google Drive: https://drive.google.com/file/d/1JQQXUEOY81HSYag60_mDM9-FCE1qdSzh/view?usp=sharing</a:t>
             </a:r>
             <a:endParaRPr lang="en-US" sz="2800" b="1" dirty="0">
               <a:solidFill>
@@ -5870,6 +5705,11 @@
                 </a:solidFill>
               </a:rPr>
               <a:t>• Presentation file (PPT or PDF) &amp; AI Disclosure Form (Y/N): YES (Updated with final empirical metrics &amp; team details)</a:t>
+            </a:r>
+          </a:p>
+          <a:p>
+            <a:r>
+              <a:t>• APK / SDK (Y/N): YES (Production Python SDK 'agentic_code_intelligence' v1.0.0 wheel in dist/ + examples/sdk_quickstart.py)</a:t>
             </a:r>
           </a:p>
         </p:txBody>
@@ -6228,44 +6068,7 @@
               </a:spcAft>
             </a:pPr>
             <a:r>
-              <a:rPr sz="2000" b="0" dirty="0">
-                <a:solidFill>
-                  <a:srgbClr val="1E1E2D"/>
-                </a:solidFill>
-              </a:rPr>
-              <a:t>• Enterprise Readiness: Version-aware index management, 51,234-vector persistent disk cache, full MTEB 2.x </a:t>
-            </a:r>
-            <a:r>
-              <a:rPr sz="2000" b="0" dirty="0" err="1">
-                <a:solidFill>
-                  <a:srgbClr val="1E1E2D"/>
-                </a:solidFill>
-              </a:rPr>
-              <a:t>EncoderProtocol</a:t>
-            </a:r>
-            <a:r>
-              <a:rPr sz="2000" b="0" dirty="0">
-                <a:solidFill>
-                  <a:srgbClr val="1E1E2D"/>
-                </a:solidFill>
-              </a:rPr>
-              <a:t> + </a:t>
-            </a:r>
-            <a:r>
-              <a:rPr sz="2000" b="0" dirty="0" err="1">
-                <a:solidFill>
-                  <a:srgbClr val="1E1E2D"/>
-                </a:solidFill>
-              </a:rPr>
-              <a:t>SearchProtocol</a:t>
-            </a:r>
-            <a:r>
-              <a:rPr sz="2000" b="0" dirty="0">
-                <a:solidFill>
-                  <a:srgbClr val="1E1E2D"/>
-                </a:solidFill>
-              </a:rPr>
-              <a:t> compliance, and 42/42 automated unit tests.</a:t>
+              <a:t>• Enterprise Readiness: Version-aware index management, 51,234-vector persistent cache, Python SDK (agentic_code_intelligence v1.0.0 in dist/), MTEB 2.x compliance, and 50/50 unit tests (100%).</a:t>
             </a:r>
           </a:p>
         </p:txBody>

</xml_diff>